<commit_message>
slides: add lede content to Jason's two new slides (Menger + worked example)
Slide bodies now track the speaker notes beat-for-beat, styled to the
warm theme (paper bg, Georgia titles, burgundy/green palette):

- Menger slide: new vertex-disjoint-paths diagram (k(A,B)=3, transparent
  PNG via render_slide_assets.menger_diagram) + theorem statement, the
  conjecture under test, and the adjacency-vs-connectivity distinction
- Worked-example slide: the real Misdirection/workplace passage verbatim
  in a quote box with concept/context attribution, plus the OOD
  train-3/test-1 logic and negatives-as-experimental-variable

Visually verified via PowerPoint COM export of both slides.

Co-Authored-By: Claude Fable 5 <noreply@anthropic.com>
</commit_message>
<xml_diff>
--- a/project/capstone/paper/slides/TALK_10MIN_formal_warm.pptx
+++ b/project/capstone/paper/slides/TALK_10MIN_formal_warm.pptx
@@ -6395,6 +6395,14 @@
 <file path=ppt/slides/slide4.xml><?xml version="1.0" encoding="utf-8"?>
 <p:sld xmlns:a="http://schemas.openxmlformats.org/drawingml/2006/main" xmlns:r="http://schemas.openxmlformats.org/officeDocument/2006/relationships" xmlns:p="http://schemas.openxmlformats.org/presentationml/2006/main">
   <p:cSld>
+    <p:bg>
+      <p:bgPr>
+        <a:solidFill>
+          <a:srgbClr val="FBF8F2"/>
+        </a:solidFill>
+        <a:effectLst/>
+      </p:bgPr>
+    </p:bg>
     <p:spTree>
       <p:nvGrpSpPr>
         <p:cNvPr id="1" name=""/>
@@ -6409,6 +6417,185 @@
           <a:chExt cx="0" cy="0"/>
         </a:xfrm>
       </p:grpSpPr>
+      <p:sp>
+        <p:nvSpPr>
+          <p:cNvPr id="2" name="TextBox 1"/>
+          <p:cNvSpPr txBox="1"/>
+          <p:nvPr/>
+        </p:nvSpPr>
+        <p:spPr>
+          <a:xfrm>
+            <a:off x="411480" y="201168"/>
+            <a:ext cx="11338560" cy="868680"/>
+          </a:xfrm>
+          <a:prstGeom prst="rect">
+            <a:avLst/>
+          </a:prstGeom>
+          <a:noFill/>
+        </p:spPr>
+        <p:txBody>
+          <a:bodyPr wrap="none">
+            <a:spAutoFit/>
+          </a:bodyPr>
+          <a:lstStyle/>
+          <a:p>
+            <a:pPr>
+              <a:defRPr sz="2600" b="1">
+                <a:solidFill>
+                  <a:srgbClr val="2B2B28"/>
+                </a:solidFill>
+                <a:latin typeface="Georgia"/>
+              </a:defRPr>
+            </a:pPr>
+            <a:r>
+              <a:t>Menger connectivity: the hypothesis in quantitative form</a:t>
+            </a:r>
+          </a:p>
+        </p:txBody>
+      </p:sp>
+      <p:pic>
+        <p:nvPicPr>
+          <p:cNvPr id="3" name="Picture 2" descr="menger_diagram.png"/>
+          <p:cNvPicPr>
+            <a:picLocks noChangeAspect="1"/>
+          </p:cNvPicPr>
+          <p:nvPr/>
+        </p:nvPicPr>
+        <p:blipFill>
+          <a:blip r:embed="rId3"/>
+          <a:stretch>
+            <a:fillRect/>
+          </a:stretch>
+        </p:blipFill>
+        <p:spPr>
+          <a:xfrm>
+            <a:off x="365760" y="1417320"/>
+            <a:ext cx="6492240" cy="4143312"/>
+          </a:xfrm>
+          <a:prstGeom prst="rect">
+            <a:avLst/>
+          </a:prstGeom>
+        </p:spPr>
+      </p:pic>
+      <p:sp>
+        <p:nvSpPr>
+          <p:cNvPr id="4" name="TextBox 3"/>
+          <p:cNvSpPr txBox="1"/>
+          <p:nvPr/>
+        </p:nvSpPr>
+        <p:spPr>
+          <a:xfrm>
+            <a:off x="7040880" y="1554480"/>
+            <a:ext cx="4754880" cy="4846320"/>
+          </a:xfrm>
+          <a:prstGeom prst="rect">
+            <a:avLst/>
+          </a:prstGeom>
+          <a:noFill/>
+        </p:spPr>
+        <p:txBody>
+          <a:bodyPr wrap="square">
+            <a:spAutoFit/>
+          </a:bodyPr>
+          <a:lstStyle/>
+          <a:p>
+            <a:pPr>
+              <a:spcAft>
+                <a:spcPts val="1000"/>
+              </a:spcAft>
+              <a:defRPr sz="1700" b="1" i="0">
+                <a:solidFill>
+                  <a:srgbClr val="2B2B28"/>
+                </a:solidFill>
+                <a:latin typeface="Calibri"/>
+              </a:defRPr>
+            </a:pPr>
+            <a:r>
+              <a:t>Menger's theorem:</a:t>
+            </a:r>
+          </a:p>
+          <a:p>
+            <a:pPr>
+              <a:spcAft>
+                <a:spcPts val="1000"/>
+              </a:spcAft>
+              <a:defRPr sz="1600" b="0" i="0">
+                <a:solidFill>
+                  <a:srgbClr val="2B2B28"/>
+                </a:solidFill>
+                <a:latin typeface="Calibri"/>
+              </a:defRPr>
+            </a:pPr>
+            <a:r>
+              <a:t>the number of vertex-disjoint paths between A and B equals the minimum number of nodes whose removal disconnects them.</a:t>
+            </a:r>
+          </a:p>
+          <a:p>
+            <a:pPr>
+              <a:spcAft>
+                <a:spcPts val="1000"/>
+              </a:spcAft>
+              <a:defRPr sz="1600" b="0" i="0">
+                <a:solidFill>
+                  <a:srgbClr val="2B2B28"/>
+                </a:solidFill>
+                <a:latin typeface="Calibri"/>
+              </a:defRPr>
+            </a:pPr>
+            <a:r>
+              <a:t>k(A, B) counts the genuinely independent routes between two concepts.</a:t>
+            </a:r>
+          </a:p>
+          <a:p>
+            <a:pPr>
+              <a:spcAft>
+                <a:spcPts val="1000"/>
+              </a:spcAft>
+              <a:defRPr sz="1600" b="1" i="0">
+                <a:solidFill>
+                  <a:srgbClr val="2B2B28"/>
+                </a:solidFill>
+                <a:latin typeface="Calibri"/>
+              </a:defRPr>
+            </a:pPr>
+            <a:r>
+              <a:t>The conjecture under test: probe benefit increases with k — the other relationships triangulate the A–B boundary with no direct A-vs-B data.</a:t>
+            </a:r>
+          </a:p>
+          <a:p>
+            <a:pPr>
+              <a:spcAft>
+                <a:spcPts val="1000"/>
+              </a:spcAft>
+              <a:defRPr sz="1600" b="1" i="0">
+                <a:solidFill>
+                  <a:srgbClr val="8C2D2D"/>
+                </a:solidFill>
+                <a:latin typeface="Calibri"/>
+              </a:defRPr>
+            </a:pPr>
+            <a:r>
+              <a:t>Adjacency = sharing an edge.  Connectivity = many independent paths.</a:t>
+            </a:r>
+          </a:p>
+          <a:p>
+            <a:pPr>
+              <a:spcAft>
+                <a:spcPts val="1000"/>
+              </a:spcAft>
+              <a:defRPr sz="1500" b="0" i="1">
+                <a:solidFill>
+                  <a:srgbClr val="6E6A62"/>
+                </a:solidFill>
+                <a:latin typeface="Calibri"/>
+              </a:defRPr>
+            </a:pPr>
+            <a:r>
+              <a:t>The results separate these two.</a:t>
+            </a:r>
+          </a:p>
+        </p:txBody>
+      </p:sp>
     </p:spTree>
     <p:extLst>
       <p:ext uri="{BB962C8B-B14F-4D97-AF65-F5344CB8AC3E}">
@@ -6652,6 +6839,14 @@
 <file path=ppt/slides/slide6.xml><?xml version="1.0" encoding="utf-8"?>
 <p:sld xmlns:a="http://schemas.openxmlformats.org/drawingml/2006/main" xmlns:r="http://schemas.openxmlformats.org/officeDocument/2006/relationships" xmlns:p="http://schemas.openxmlformats.org/presentationml/2006/main">
   <p:cSld>
+    <p:bg>
+      <p:bgPr>
+        <a:solidFill>
+          <a:srgbClr val="FBF8F2"/>
+        </a:solidFill>
+        <a:effectLst/>
+      </p:bgPr>
+    </p:bg>
     <p:spTree>
       <p:nvGrpSpPr>
         <p:cNvPr id="1" name=""/>
@@ -6666,6 +6861,213 @@
           <a:chExt cx="0" cy="0"/>
         </a:xfrm>
       </p:grpSpPr>
+      <p:sp>
+        <p:nvSpPr>
+          <p:cNvPr id="2" name="TextBox 1"/>
+          <p:cNvSpPr txBox="1"/>
+          <p:nvPr/>
+        </p:nvSpPr>
+        <p:spPr>
+          <a:xfrm>
+            <a:off x="411480" y="201168"/>
+            <a:ext cx="11338560" cy="868680"/>
+          </a:xfrm>
+          <a:prstGeom prst="rect">
+            <a:avLst/>
+          </a:prstGeom>
+          <a:noFill/>
+        </p:spPr>
+        <p:txBody>
+          <a:bodyPr wrap="none">
+            <a:spAutoFit/>
+          </a:bodyPr>
+          <a:lstStyle/>
+          <a:p>
+            <a:pPr>
+              <a:defRPr sz="2600" b="1">
+                <a:solidFill>
+                  <a:srgbClr val="2B2B28"/>
+                </a:solidFill>
+                <a:latin typeface="Georgia"/>
+              </a:defRPr>
+            </a:pPr>
+            <a:r>
+              <a:t>A worked example: one passage, one probe, one test</a:t>
+            </a:r>
+          </a:p>
+        </p:txBody>
+      </p:sp>
+      <p:sp>
+        <p:nvSpPr>
+          <p:cNvPr id="3" name="Rounded Rectangle 2"/>
+          <p:cNvSpPr/>
+          <p:nvPr/>
+        </p:nvSpPr>
+        <p:spPr>
+          <a:xfrm>
+            <a:off x="548640" y="1234440"/>
+            <a:ext cx="11064240" cy="1783080"/>
+          </a:xfrm>
+          <a:prstGeom prst="roundRect">
+            <a:avLst/>
+          </a:prstGeom>
+          <a:solidFill>
+            <a:srgbClr val="F2EBDE"/>
+          </a:solidFill>
+          <a:ln w="15875">
+            <a:solidFill>
+              <a:srgbClr val="3A6351"/>
+            </a:solidFill>
+          </a:ln>
+        </p:spPr>
+        <p:style>
+          <a:lnRef idx="1">
+            <a:schemeClr val="accent1"/>
+          </a:lnRef>
+          <a:fillRef idx="3">
+            <a:schemeClr val="accent1"/>
+          </a:fillRef>
+          <a:effectRef idx="2">
+            <a:schemeClr val="accent1"/>
+          </a:effectRef>
+          <a:fontRef idx="minor">
+            <a:schemeClr val="lt1"/>
+          </a:fontRef>
+        </p:style>
+        <p:txBody>
+          <a:bodyPr rtlCol="0" anchor="ctr" wrap="square" lIns="228600" rIns="228600" tIns="109728"/>
+          <a:lstStyle/>
+          <a:p>
+            <a:pPr algn="ctr">
+              <a:defRPr sz="1600" i="1">
+                <a:solidFill>
+                  <a:srgbClr val="2B2B28"/>
+                </a:solidFill>
+                <a:latin typeface="Georgia"/>
+              </a:defRPr>
+            </a:pPr>
+            <a:r>
+              <a:t>“When the client asked why the launch date had slipped by three weeks, the project lead smiled and pulled up a different slide. ‘Before we get into timelines, let me show you the incredible engagement numbers from the beta — these are honestly the most exciting metrics I’ve seen all year.’”</a:t>
+            </a:r>
+          </a:p>
+          <a:p>
+            <a:pPr>
+              <a:defRPr sz="1300" b="1">
+                <a:solidFill>
+                  <a:srgbClr val="3A6351"/>
+                </a:solidFill>
+                <a:latin typeface="Calibri"/>
+              </a:defRPr>
+            </a:pPr>
+            <a:r>
+              <a:t>concept: Misdirection   ·   context: workplace   ·   an actual passage from the dataset</a:t>
+            </a:r>
+          </a:p>
+        </p:txBody>
+      </p:sp>
+      <p:sp>
+        <p:nvSpPr>
+          <p:cNvPr id="4" name="TextBox 3"/>
+          <p:cNvSpPr txBox="1"/>
+          <p:nvPr/>
+        </p:nvSpPr>
+        <p:spPr>
+          <a:xfrm>
+            <a:off x="640080" y="3246120"/>
+            <a:ext cx="10972800" cy="3200400"/>
+          </a:xfrm>
+          <a:prstGeom prst="rect">
+            <a:avLst/>
+          </a:prstGeom>
+          <a:noFill/>
+        </p:spPr>
+        <p:txBody>
+          <a:bodyPr wrap="square">
+            <a:spAutoFit/>
+          </a:bodyPr>
+          <a:lstStyle/>
+          <a:p>
+            <a:pPr>
+              <a:spcAft>
+                <a:spcPts val="1000"/>
+              </a:spcAft>
+              <a:defRPr sz="1600" b="0" i="0">
+                <a:solidFill>
+                  <a:srgbClr val="2B2B28"/>
+                </a:solidFill>
+                <a:latin typeface="Calibri"/>
+              </a:defRPr>
+            </a:pPr>
+            <a:r>
+              <a:t>The concept is never named — the behaviour is shown, not labelled.</a:t>
+            </a:r>
+          </a:p>
+          <a:p>
+            <a:pPr>
+              <a:spcAft>
+                <a:spcPts val="1000"/>
+              </a:spcAft>
+              <a:defRPr sz="1600" b="0" i="0">
+                <a:solidFill>
+                  <a:srgbClr val="2B2B28"/>
+                </a:solidFill>
+                <a:latin typeface="Calibri"/>
+              </a:defRPr>
+            </a:pPr>
+            <a:r>
+              <a:t>280 passages per concept · 4 surface-distinct contexts: workplace · online · relationships · marketplace.</a:t>
+            </a:r>
+          </a:p>
+          <a:p>
+            <a:pPr>
+              <a:spcAft>
+                <a:spcPts val="1000"/>
+              </a:spcAft>
+              <a:defRPr sz="1600" b="1" i="0">
+                <a:solidFill>
+                  <a:srgbClr val="2B2B28"/>
+                </a:solidFill>
+                <a:latin typeface="Calibri"/>
+              </a:defRPr>
+            </a:pPr>
+            <a:r>
+              <a:t>Train on 3 contexts → test on the held-out 4th: the probe must recognise the behaviour, not the vocabulary.</a:t>
+            </a:r>
+          </a:p>
+          <a:p>
+            <a:pPr>
+              <a:spcAft>
+                <a:spcPts val="1000"/>
+              </a:spcAft>
+              <a:defRPr sz="1600" b="1" i="0">
+                <a:solidFill>
+                  <a:srgbClr val="8C2D2D"/>
+                </a:solidFill>
+                <a:latin typeface="Calibri"/>
+              </a:defRPr>
+            </a:pPr>
+            <a:r>
+              <a:t>The experimental variable: which negatives the probe trains against —</a:t>
+            </a:r>
+          </a:p>
+          <a:p>
+            <a:pPr>
+              <a:spcAft>
+                <a:spcPts val="1000"/>
+              </a:spcAft>
+              <a:defRPr sz="1500" b="0" i="0">
+                <a:solidFill>
+                  <a:srgbClr val="8C2D2D"/>
+                </a:solidFill>
+                <a:latin typeface="Calibri"/>
+              </a:defRPr>
+            </a:pPr>
+            <a:r>
+              <a:t>random unrelated concepts  vs  graph siblings (e.g. ManipulativeCommunication, Misdirection's nearest confuser).</a:t>
+            </a:r>
+          </a:p>
+        </p:txBody>
+      </p:sp>
     </p:spTree>
     <p:extLst>
       <p:ext uri="{BB962C8B-B14F-4D97-AF65-F5344CB8AC3E}">

</xml_diff>

<commit_message>
explorers: strip coursework predict-prompts for a research audience
The R3/R4 results explorers carried ARENA-style "predict before you run"
prompts from the prep-notebook house style. Removed for the research
deliverable; refreshes the warm deck alongside. Pending since 2026-06-15,
committed now with the near-OOS work.

Co-Authored-By: Claude Opus 5 <noreply@anthropic.com>
</commit_message>
<xml_diff>
--- a/project/capstone/paper/slides/TALK_10MIN_formal_warm.pptx
+++ b/project/capstone/paper/slides/TALK_10MIN_formal_warm.pptx
@@ -11,9 +11,9 @@
     <p:sldId id="256" r:id="rId2"/>
     <p:sldId id="267" r:id="rId3"/>
     <p:sldId id="268" r:id="rId4"/>
-    <p:sldId id="277" r:id="rId5"/>
+    <p:sldId id="279" r:id="rId5"/>
     <p:sldId id="269" r:id="rId6"/>
-    <p:sldId id="278" r:id="rId7"/>
+    <p:sldId id="280" r:id="rId7"/>
     <p:sldId id="270" r:id="rId8"/>
     <p:sldId id="271" r:id="rId9"/>
     <p:sldId id="272" r:id="rId10"/>
@@ -1011,7 +1011,13 @@
   <p:cSld>
     <p:spTree>
       <p:nvGrpSpPr>
-        <p:cNvPr id="1" name=""/>
+        <p:cNvPr id="1" name="">
+          <a:extLst>
+            <a:ext uri="{FF2B5EF4-FFF2-40B4-BE49-F238E27FC236}">
+              <a16:creationId xmlns:a16="http://schemas.microsoft.com/office/drawing/2014/main" id="{F9AAF348-3DA5-67A2-258A-E64C83B0B215}"/>
+            </a:ext>
+          </a:extLst>
+        </p:cNvPr>
         <p:cNvGrpSpPr/>
         <p:nvPr/>
       </p:nvGrpSpPr>
@@ -1025,63 +1031,72 @@
       </p:grpSpPr>
       <p:sp>
         <p:nvSpPr>
-          <p:cNvPr id="2" name="Slide Image Placeholder 1"/>
+          <p:cNvPr id="2" name="Slide Image Placeholder 1">
+            <a:extLst>
+              <a:ext uri="{FF2B5EF4-FFF2-40B4-BE49-F238E27FC236}">
+                <a16:creationId xmlns:a16="http://schemas.microsoft.com/office/drawing/2014/main" id="{AF5F1A5B-E8BD-99FB-DED0-6025B1329BC2}"/>
+              </a:ext>
+            </a:extLst>
+          </p:cNvPr>
           <p:cNvSpPr>
             <a:spLocks noGrp="1" noRot="1" noChangeAspect="1"/>
           </p:cNvSpPr>
           <p:nvPr>
-            <p:ph type="sldImg"/>
-          </p:nvPr>
-        </p:nvSpPr>
-        <p:spPr>
-          <a:xfrm>
-            <a:off x="685800" y="1143000"/>
-            <a:ext cx="5486400" cy="3086100"/>
-          </a:xfrm>
-          <a:prstGeom prst="rect">
-            <a:avLst/>
-          </a:prstGeom>
-          <a:noFill/>
-          <a:ln w="12700">
-            <a:solidFill>
-              <a:prstClr val="black"/>
-            </a:solidFill>
-          </a:ln>
-        </p:spPr>
-      </p:sp>
-      <p:sp>
-        <p:nvSpPr>
-          <p:cNvPr id="3" name="Notes Placeholder 2"/>
+            <p:ph type="sldImg" idx="2"/>
+          </p:nvPr>
+        </p:nvSpPr>
+        <p:spPr/>
+      </p:sp>
+      <p:sp>
+        <p:nvSpPr>
+          <p:cNvPr id="3" name="Notes Placeholder 2">
+            <a:extLst>
+              <a:ext uri="{FF2B5EF4-FFF2-40B4-BE49-F238E27FC236}">
+                <a16:creationId xmlns:a16="http://schemas.microsoft.com/office/drawing/2014/main" id="{BA2841C1-3F7B-BF86-660A-7D2E581F40AB}"/>
+              </a:ext>
+            </a:extLst>
+          </p:cNvPr>
           <p:cNvSpPr>
             <a:spLocks noGrp="1"/>
           </p:cNvSpPr>
           <p:nvPr>
-            <p:ph type="body" idx="1"/>
-          </p:nvPr>
-        </p:nvSpPr>
-        <p:spPr>
-          <a:xfrm>
-            <a:off x="685800" y="4400550"/>
-            <a:ext cx="5486400" cy="3600450"/>
-          </a:xfrm>
-          <a:prstGeom prst="rect">
-            <a:avLst/>
-          </a:prstGeom>
-        </p:spPr>
+            <p:ph type="body" sz="quarter" idx="3"/>
+          </p:nvPr>
+        </p:nvSpPr>
+        <p:spPr/>
         <p:txBody>
           <a:bodyPr/>
           <a:lstStyle/>
           <a:p>
             <a:r>
+              <a:rPr lang="en-US" dirty="0"/>
               <a:t>Menger's theorem is a result from graph theory. It states that the number of vertex-disjoint paths between two nodes — routes that share no intermediate node — equals the minimum number of nodes that must be removed to disconnect them. It is, in effect, a measure of how many genuinely independent routes connect two points. Applied to the concept graph, the conjecture is this: if concept A and concept B are connected by many independent paths through other concepts, the relationships along those paths should allow a probe to triangulate the boundary between A and B without any direct A-versus-B training data — much as two surveyed borders can pin down a third that has never been surveyed directly. Menger connectivity, written k(A,B), gives the hypothesis its quantitative form: the benefit of relational training should increase with k. That is the claim iterations 2 and 4 test directly. The distinction to hold onto throughout is between adjacency — two concepts sharing an edge — and connectivity — many independent paths between them. The results show the first helps and the second does not. (0:50)</a:t>
             </a:r>
           </a:p>
         </p:txBody>
+      </p:sp>
+      <p:sp>
+        <p:nvSpPr>
+          <p:cNvPr id="4" name="Slide Number Placeholder 3">
+            <a:extLst>
+              <a:ext uri="{FF2B5EF4-FFF2-40B4-BE49-F238E27FC236}">
+                <a16:creationId xmlns:a16="http://schemas.microsoft.com/office/drawing/2014/main" id="{584FA95E-85DA-F967-756F-E195C9EE4C42}"/>
+              </a:ext>
+            </a:extLst>
+          </p:cNvPr>
+          <p:cNvSpPr>
+            <a:spLocks noGrp="1"/>
+          </p:cNvSpPr>
+          <p:nvPr>
+            <p:ph type="sldNum" sz="quarter" idx="5"/>
+          </p:nvPr>
+        </p:nvSpPr>
+        <p:spPr/>
       </p:sp>
     </p:spTree>
     <p:extLst>
       <p:ext uri="{BB962C8B-B14F-4D97-AF65-F5344CB8AC3E}">
-        <p14:creationId xmlns:p14="http://schemas.microsoft.com/office/powerpoint/2010/main" val="4031393008"/>
+        <p14:creationId xmlns:p14="http://schemas.microsoft.com/office/powerpoint/2010/main" val="1587372584"/>
       </p:ext>
     </p:extLst>
   </p:cSld>
@@ -1196,7 +1211,13 @@
   <p:cSld>
     <p:spTree>
       <p:nvGrpSpPr>
-        <p:cNvPr id="1" name=""/>
+        <p:cNvPr id="1" name="">
+          <a:extLst>
+            <a:ext uri="{FF2B5EF4-FFF2-40B4-BE49-F238E27FC236}">
+              <a16:creationId xmlns:a16="http://schemas.microsoft.com/office/drawing/2014/main" id="{9DB8367B-56EB-03E3-DADB-D7E3E8432B47}"/>
+            </a:ext>
+          </a:extLst>
+        </p:cNvPr>
         <p:cNvGrpSpPr/>
         <p:nvPr/>
       </p:nvGrpSpPr>
@@ -1210,63 +1231,120 @@
       </p:grpSpPr>
       <p:sp>
         <p:nvSpPr>
-          <p:cNvPr id="2" name="Slide Image Placeholder 1"/>
+          <p:cNvPr id="2" name="Slide Image Placeholder 1">
+            <a:extLst>
+              <a:ext uri="{FF2B5EF4-FFF2-40B4-BE49-F238E27FC236}">
+                <a16:creationId xmlns:a16="http://schemas.microsoft.com/office/drawing/2014/main" id="{614E74F0-80C2-0BE8-2673-AA3161F671A2}"/>
+              </a:ext>
+            </a:extLst>
+          </p:cNvPr>
           <p:cNvSpPr>
             <a:spLocks noGrp="1" noRot="1" noChangeAspect="1"/>
           </p:cNvSpPr>
           <p:nvPr>
-            <p:ph type="sldImg"/>
-          </p:nvPr>
-        </p:nvSpPr>
-        <p:spPr>
-          <a:xfrm>
-            <a:off x="685800" y="1143000"/>
-            <a:ext cx="5486400" cy="3086100"/>
-          </a:xfrm>
-          <a:prstGeom prst="rect">
-            <a:avLst/>
-          </a:prstGeom>
-          <a:noFill/>
-          <a:ln w="12700">
-            <a:solidFill>
-              <a:prstClr val="black"/>
-            </a:solidFill>
-          </a:ln>
-        </p:spPr>
-      </p:sp>
-      <p:sp>
-        <p:nvSpPr>
-          <p:cNvPr id="3" name="Notes Placeholder 2"/>
+            <p:ph type="sldImg" idx="2"/>
+          </p:nvPr>
+        </p:nvSpPr>
+        <p:spPr/>
+      </p:sp>
+      <p:sp>
+        <p:nvSpPr>
+          <p:cNvPr id="3" name="Notes Placeholder 2">
+            <a:extLst>
+              <a:ext uri="{FF2B5EF4-FFF2-40B4-BE49-F238E27FC236}">
+                <a16:creationId xmlns:a16="http://schemas.microsoft.com/office/drawing/2014/main" id="{5608C0E4-2720-27E0-42A1-C45A866204FD}"/>
+              </a:ext>
+            </a:extLst>
+          </p:cNvPr>
           <p:cNvSpPr>
             <a:spLocks noGrp="1"/>
           </p:cNvSpPr>
           <p:nvPr>
-            <p:ph type="body" idx="1"/>
-          </p:nvPr>
-        </p:nvSpPr>
-        <p:spPr>
-          <a:xfrm>
-            <a:off x="685800" y="4400550"/>
-            <a:ext cx="5486400" cy="3600450"/>
-          </a:xfrm>
-          <a:prstGeom prst="rect">
-            <a:avLst/>
-          </a:prstGeom>
-        </p:spPr>
+            <p:ph type="body" sz="quarter" idx="3"/>
+          </p:nvPr>
+        </p:nvSpPr>
+        <p:spPr/>
         <p:txBody>
           <a:bodyPr/>
           <a:lstStyle/>
           <a:p>
             <a:r>
-              <a:t>A concrete example grounds the design. The following is an actual passage from the dataset, generated for the concept Misdirection in the workplace context: “When the client asked why the launch date had slipped by three weeks, the project lead smiled and pulled up a different slide. ‘Before we get into timelines, let me show you the incredible engagement numbers from the beta — these are honestly the most exciting metrics I’ve seen all year.’” Note that no passage ever names its concept; the behaviour is shown, not labelled. Each of the 15 concepts has 280 such passages, spread across four surface-distinct contexts — workplace, online, personal relationships, and marketplace — which differ sharply in vocabulary but not in the underlying behaviour. The probe for Misdirection is trained on passages from three of those contexts and tested on the held-out fourth, so it cannot succeed by memorising office vocabulary; it must recognise the behaviour itself in a setting it has never seen. At test time the probe must separate held-out Misdirection passages from negative examples — and which negatives it is trained against is the experimental variable: unrelated concepts drawn at random, or its graph siblings, such as ManipulativeCommunication, the concept Misdirection is most readily confused with. (0:55)</a:t>
-            </a:r>
-          </a:p>
-        </p:txBody>
+              <a:rPr lang="en-US" dirty="0"/>
+              <a:t>A concrete example grounds the design. The following is an actual passage from the dataset, generated for the concept Misdirection in the workplace context: “When the client asked why the launch date had slipped by three weeks, the project lead smiled and pulled up a different slide. ‘Before we get into timelines, let me show you the incredible engagement numbers from the beta — these are honestly the most exciting metrics I’ve seen all year.’” Note that no passage ever names its concept; the </a:t>
+            </a:r>
+            <a:r>
+              <a:rPr lang="en-US" dirty="0" err="1"/>
+              <a:t>behaviour</a:t>
+            </a:r>
+            <a:r>
+              <a:rPr lang="en-US" dirty="0"/>
+              <a:t> is shown, not labelled. Each of the 15 concepts has 280 such passages, spread across four surface-distinct contexts — workplace, online, personal relationships, and marketplace — which differ sharply in vocabulary but not in the underlying </a:t>
+            </a:r>
+            <a:r>
+              <a:rPr lang="en-US" dirty="0" err="1"/>
+              <a:t>behaviour</a:t>
+            </a:r>
+            <a:r>
+              <a:rPr lang="en-US" dirty="0"/>
+              <a:t>. The probe for Misdirection is trained on passages from three of those contexts and tested on the held-out fourth, so it cannot succeed by </a:t>
+            </a:r>
+            <a:r>
+              <a:rPr lang="en-US" dirty="0" err="1"/>
+              <a:t>memorising</a:t>
+            </a:r>
+            <a:r>
+              <a:rPr lang="en-US" dirty="0"/>
+              <a:t> office vocabulary; it must </a:t>
+            </a:r>
+            <a:r>
+              <a:rPr lang="en-US" dirty="0" err="1"/>
+              <a:t>recognise</a:t>
+            </a:r>
+            <a:r>
+              <a:rPr lang="en-US" dirty="0"/>
+              <a:t> the </a:t>
+            </a:r>
+            <a:r>
+              <a:rPr lang="en-US" dirty="0" err="1"/>
+              <a:t>behaviour</a:t>
+            </a:r>
+            <a:r>
+              <a:rPr lang="en-US" dirty="0"/>
+              <a:t> itself in a setting it has never seen. At test time the probe must separate held-out Misdirection passages from negative examples — and which negatives it is trained against is the experimental variable: unrelated concepts drawn at random, or its graph siblings, such as </a:t>
+            </a:r>
+            <a:r>
+              <a:rPr lang="en-US" dirty="0" err="1"/>
+              <a:t>ManipulativeCommunication</a:t>
+            </a:r>
+            <a:r>
+              <a:rPr lang="en-US" dirty="0"/>
+              <a:t>, the concept Misdirection is most readily confused with. (0:55)</a:t>
+            </a:r>
+          </a:p>
+        </p:txBody>
+      </p:sp>
+      <p:sp>
+        <p:nvSpPr>
+          <p:cNvPr id="4" name="Slide Number Placeholder 3">
+            <a:extLst>
+              <a:ext uri="{FF2B5EF4-FFF2-40B4-BE49-F238E27FC236}">
+                <a16:creationId xmlns:a16="http://schemas.microsoft.com/office/drawing/2014/main" id="{B2FF0964-81D7-F7F3-DD7D-AEB5BA85C288}"/>
+              </a:ext>
+            </a:extLst>
+          </p:cNvPr>
+          <p:cNvSpPr>
+            <a:spLocks noGrp="1"/>
+          </p:cNvSpPr>
+          <p:nvPr>
+            <p:ph type="sldNum" sz="quarter" idx="5"/>
+          </p:nvPr>
+        </p:nvSpPr>
+        <p:spPr/>
       </p:sp>
     </p:spTree>
     <p:extLst>
       <p:ext uri="{BB962C8B-B14F-4D97-AF65-F5344CB8AC3E}">
-        <p14:creationId xmlns:p14="http://schemas.microsoft.com/office/powerpoint/2010/main" val="1820815696"/>
+        <p14:creationId xmlns:p14="http://schemas.microsoft.com/office/powerpoint/2010/main" val="3113364598"/>
       </p:ext>
     </p:extLst>
   </p:cSld>
@@ -6405,7 +6483,13 @@
     </p:bg>
     <p:spTree>
       <p:nvGrpSpPr>
-        <p:cNvPr id="1" name=""/>
+        <p:cNvPr id="1" name="">
+          <a:extLst>
+            <a:ext uri="{FF2B5EF4-FFF2-40B4-BE49-F238E27FC236}">
+              <a16:creationId xmlns:a16="http://schemas.microsoft.com/office/drawing/2014/main" id="{A7A0BAD3-13C7-9297-DB74-3D143C1194D6}"/>
+            </a:ext>
+          </a:extLst>
+        </p:cNvPr>
         <p:cNvGrpSpPr/>
         <p:nvPr/>
       </p:nvGrpSpPr>
@@ -6419,14 +6503,20 @@
       </p:grpSpPr>
       <p:sp>
         <p:nvSpPr>
-          <p:cNvPr id="2" name="TextBox 1"/>
+          <p:cNvPr id="7" name="TextBox 6">
+            <a:extLst>
+              <a:ext uri="{FF2B5EF4-FFF2-40B4-BE49-F238E27FC236}">
+                <a16:creationId xmlns:a16="http://schemas.microsoft.com/office/drawing/2014/main" id="{D451A20A-DFA8-AF70-18D0-F7581749EC7A}"/>
+              </a:ext>
+            </a:extLst>
+          </p:cNvPr>
           <p:cNvSpPr txBox="1"/>
           <p:nvPr/>
         </p:nvSpPr>
         <p:spPr>
           <a:xfrm>
-            <a:off x="411480" y="201168"/>
-            <a:ext cx="11338560" cy="868680"/>
+            <a:off x="457198" y="587823"/>
+            <a:ext cx="11571515" cy="1077218"/>
           </a:xfrm>
           <a:prstGeom prst="rect">
             <a:avLst/>
@@ -6434,7 +6524,7 @@
           <a:noFill/>
         </p:spPr>
         <p:txBody>
-          <a:bodyPr wrap="none">
+          <a:bodyPr wrap="square">
             <a:spAutoFit/>
           </a:bodyPr>
           <a:lstStyle/>
@@ -6448,6 +6538,7 @@
               </a:defRPr>
             </a:pPr>
             <a:r>
+              <a:rPr lang="en-US" sz="3200" dirty="0"/>
               <a:t>Menger connectivity: the hypothesis in quantitative form</a:t>
             </a:r>
           </a:p>
@@ -6455,7 +6546,7 @@
       </p:sp>
       <p:pic>
         <p:nvPicPr>
-          <p:cNvPr id="3" name="Picture 2" descr="menger_diagram.png"/>
+          <p:cNvPr id="2" name="Picture 1" descr="menger_diagram.png"/>
           <p:cNvPicPr>
             <a:picLocks noChangeAspect="1"/>
           </p:cNvPicPr>
@@ -6469,7 +6560,7 @@
         </p:blipFill>
         <p:spPr>
           <a:xfrm>
-            <a:off x="365760" y="1417320"/>
+            <a:off x="365760" y="1907177"/>
             <a:ext cx="6492240" cy="4143312"/>
           </a:xfrm>
           <a:prstGeom prst="rect">
@@ -6479,14 +6570,20 @@
       </p:pic>
       <p:sp>
         <p:nvSpPr>
-          <p:cNvPr id="4" name="TextBox 3"/>
+          <p:cNvPr id="5" name="TextBox 4">
+            <a:extLst>
+              <a:ext uri="{FF2B5EF4-FFF2-40B4-BE49-F238E27FC236}">
+                <a16:creationId xmlns:a16="http://schemas.microsoft.com/office/drawing/2014/main" id="{18FD1D8E-B746-BCB2-6DBF-6E75F0962AB2}"/>
+              </a:ext>
+            </a:extLst>
+          </p:cNvPr>
           <p:cNvSpPr txBox="1"/>
           <p:nvPr/>
         </p:nvSpPr>
         <p:spPr>
           <a:xfrm>
-            <a:off x="7040880" y="1554480"/>
-            <a:ext cx="4754880" cy="4846320"/>
+            <a:off x="7021286" y="2011628"/>
+            <a:ext cx="4321628" cy="3934410"/>
           </a:xfrm>
           <a:prstGeom prst="rect">
             <a:avLst/>
@@ -6511,6 +6608,7 @@
               </a:defRPr>
             </a:pPr>
             <a:r>
+              <a:rPr lang="en-US" dirty="0"/>
               <a:t>Menger's theorem:</a:t>
             </a:r>
           </a:p>
@@ -6527,6 +6625,7 @@
               </a:defRPr>
             </a:pPr>
             <a:r>
+              <a:rPr lang="en-US" dirty="0"/>
               <a:t>the number of vertex-disjoint paths between A and B equals the minimum number of nodes whose removal disconnects them.</a:t>
             </a:r>
           </a:p>
@@ -6543,6 +6642,7 @@
               </a:defRPr>
             </a:pPr>
             <a:r>
+              <a:rPr lang="en-US" dirty="0"/>
               <a:t>k(A, B) counts the genuinely independent routes between two concepts.</a:t>
             </a:r>
           </a:p>
@@ -6559,7 +6659,16 @@
               </a:defRPr>
             </a:pPr>
             <a:r>
-              <a:t>The conjecture under test: probe benefit increases with k — the other relationships triangulate the A–B boundary with no direct A-vs-B data.</a:t>
+              <a:rPr lang="en-US" dirty="0"/>
+              <a:t>The conjecture under test: probe benefit increases with k — the other relationships triangulate the A–B boundary with no direct </a:t>
+            </a:r>
+            <a:r>
+              <a:rPr lang="en-US" dirty="0" err="1"/>
+              <a:t>A-vs</a:t>
+            </a:r>
+            <a:r>
+              <a:rPr lang="en-US" dirty="0"/>
+              <a:t>-B data.</a:t>
             </a:r>
           </a:p>
           <a:p>
@@ -6575,6 +6684,7 @@
               </a:defRPr>
             </a:pPr>
             <a:r>
+              <a:rPr lang="en-US" dirty="0"/>
               <a:t>Adjacency = sharing an edge.  Connectivity = many independent paths.</a:t>
             </a:r>
           </a:p>
@@ -6591,6 +6701,7 @@
               </a:defRPr>
             </a:pPr>
             <a:r>
+              <a:rPr lang="en-US" dirty="0"/>
               <a:t>The results separate these two.</a:t>
             </a:r>
           </a:p>
@@ -6599,7 +6710,7 @@
     </p:spTree>
     <p:extLst>
       <p:ext uri="{BB962C8B-B14F-4D97-AF65-F5344CB8AC3E}">
-        <p14:creationId xmlns:p14="http://schemas.microsoft.com/office/powerpoint/2010/main" val="2433385437"/>
+        <p14:creationId xmlns:p14="http://schemas.microsoft.com/office/powerpoint/2010/main" val="1421863923"/>
       </p:ext>
     </p:extLst>
   </p:cSld>
@@ -6849,7 +6960,13 @@
     </p:bg>
     <p:spTree>
       <p:nvGrpSpPr>
-        <p:cNvPr id="1" name=""/>
+        <p:cNvPr id="1" name="">
+          <a:extLst>
+            <a:ext uri="{FF2B5EF4-FFF2-40B4-BE49-F238E27FC236}">
+              <a16:creationId xmlns:a16="http://schemas.microsoft.com/office/drawing/2014/main" id="{B1FE8CA0-0000-991D-821A-37B592A64C04}"/>
+            </a:ext>
+          </a:extLst>
+        </p:cNvPr>
         <p:cNvGrpSpPr/>
         <p:nvPr/>
       </p:nvGrpSpPr>
@@ -6863,14 +6980,20 @@
       </p:grpSpPr>
       <p:sp>
         <p:nvSpPr>
-          <p:cNvPr id="2" name="TextBox 1"/>
+          <p:cNvPr id="7" name="TextBox 6">
+            <a:extLst>
+              <a:ext uri="{FF2B5EF4-FFF2-40B4-BE49-F238E27FC236}">
+                <a16:creationId xmlns:a16="http://schemas.microsoft.com/office/drawing/2014/main" id="{BD5CB133-A549-C258-9F55-76E8243A1743}"/>
+              </a:ext>
+            </a:extLst>
+          </p:cNvPr>
           <p:cNvSpPr txBox="1"/>
           <p:nvPr/>
         </p:nvSpPr>
         <p:spPr>
           <a:xfrm>
-            <a:off x="411480" y="201168"/>
-            <a:ext cx="11338560" cy="868680"/>
+            <a:off x="457199" y="587823"/>
+            <a:ext cx="7467601" cy="1077218"/>
           </a:xfrm>
           <a:prstGeom prst="rect">
             <a:avLst/>
@@ -6878,7 +7001,7 @@
           <a:noFill/>
         </p:spPr>
         <p:txBody>
-          <a:bodyPr wrap="none">
+          <a:bodyPr wrap="square">
             <a:spAutoFit/>
           </a:bodyPr>
           <a:lstStyle/>
@@ -6892,8 +7015,10 @@
               </a:defRPr>
             </a:pPr>
             <a:r>
+              <a:rPr lang="en-US" sz="3200"/>
               <a:t>A worked example: one passage, one probe, one test</a:t>
             </a:r>
+            <a:endParaRPr lang="en-US" sz="3200" dirty="0"/>
           </a:p>
         </p:txBody>
       </p:sp>
@@ -6905,7 +7030,7 @@
         </p:nvSpPr>
         <p:spPr>
           <a:xfrm>
-            <a:off x="548640" y="1234440"/>
+            <a:off x="548640" y="1800386"/>
             <a:ext cx="11064240" cy="1783080"/>
           </a:xfrm>
           <a:prstGeom prst="roundRect">
@@ -6935,7 +7060,7 @@
           </a:fontRef>
         </p:style>
         <p:txBody>
-          <a:bodyPr rtlCol="0" anchor="ctr" wrap="square" lIns="228600" rIns="228600" tIns="109728"/>
+          <a:bodyPr wrap="square" lIns="228600" tIns="109728" rIns="228600" rtlCol="0" anchor="ctr"/>
           <a:lstStyle/>
           <a:p>
             <a:pPr algn="ctr">
@@ -6947,6 +7072,7 @@
               </a:defRPr>
             </a:pPr>
             <a:r>
+              <a:rPr dirty="0"/>
               <a:t>“When the client asked why the launch date had slipped by three weeks, the project lead smiled and pulled up a different slide. ‘Before we get into timelines, let me show you the incredible engagement numbers from the beta — these are honestly the most exciting metrics I’ve seen all year.’”</a:t>
             </a:r>
           </a:p>
@@ -6959,7 +7085,19 @@
                 <a:latin typeface="Calibri"/>
               </a:defRPr>
             </a:pPr>
-            <a:r>
+            <a:endParaRPr lang="en-AU" dirty="0"/>
+          </a:p>
+          <a:p>
+            <a:pPr algn="ctr">
+              <a:defRPr sz="1300" b="1">
+                <a:solidFill>
+                  <a:srgbClr val="3A6351"/>
+                </a:solidFill>
+                <a:latin typeface="Calibri"/>
+              </a:defRPr>
+            </a:pPr>
+            <a:r>
+              <a:rPr dirty="0"/>
               <a:t>concept: Misdirection   ·   context: workplace   ·   an actual passage from the dataset</a:t>
             </a:r>
           </a:p>
@@ -6967,14 +7105,20 @@
       </p:sp>
       <p:sp>
         <p:nvSpPr>
-          <p:cNvPr id="4" name="TextBox 3"/>
+          <p:cNvPr id="6" name="TextBox 5">
+            <a:extLst>
+              <a:ext uri="{FF2B5EF4-FFF2-40B4-BE49-F238E27FC236}">
+                <a16:creationId xmlns:a16="http://schemas.microsoft.com/office/drawing/2014/main" id="{522E3196-C7E4-C19F-DF6A-055CF4FD0BE1}"/>
+              </a:ext>
+            </a:extLst>
+          </p:cNvPr>
           <p:cNvSpPr txBox="1"/>
           <p:nvPr/>
         </p:nvSpPr>
         <p:spPr>
           <a:xfrm>
-            <a:off x="640080" y="3246120"/>
-            <a:ext cx="10972800" cy="3200400"/>
+            <a:off x="548640" y="3956529"/>
+            <a:ext cx="9144000" cy="2067233"/>
           </a:xfrm>
           <a:prstGeom prst="rect">
             <a:avLst/>
@@ -6999,7 +7143,16 @@
               </a:defRPr>
             </a:pPr>
             <a:r>
-              <a:t>The concept is never named — the behaviour is shown, not labelled.</a:t>
+              <a:rPr lang="en-US" dirty="0"/>
+              <a:t>The concept is never named — the </a:t>
+            </a:r>
+            <a:r>
+              <a:rPr lang="en-US" dirty="0" err="1"/>
+              <a:t>behaviour</a:t>
+            </a:r>
+            <a:r>
+              <a:rPr lang="en-US" dirty="0"/>
+              <a:t> is shown, not labelled.</a:t>
             </a:r>
           </a:p>
           <a:p>
@@ -7015,6 +7168,7 @@
               </a:defRPr>
             </a:pPr>
             <a:r>
+              <a:rPr lang="en-US" dirty="0"/>
               <a:t>280 passages per concept · 4 surface-distinct contexts: workplace · online · relationships · marketplace.</a:t>
             </a:r>
           </a:p>
@@ -7031,7 +7185,24 @@
               </a:defRPr>
             </a:pPr>
             <a:r>
-              <a:t>Train on 3 contexts → test on the held-out 4th: the probe must recognise the behaviour, not the vocabulary.</a:t>
+              <a:rPr lang="en-US" dirty="0"/>
+              <a:t>Train on 3 contexts → test on the held-out 4th: the probe must </a:t>
+            </a:r>
+            <a:r>
+              <a:rPr lang="en-US" dirty="0" err="1"/>
+              <a:t>recognise</a:t>
+            </a:r>
+            <a:r>
+              <a:rPr lang="en-US" dirty="0"/>
+              <a:t> the </a:t>
+            </a:r>
+            <a:r>
+              <a:rPr lang="en-US" dirty="0" err="1"/>
+              <a:t>behaviour</a:t>
+            </a:r>
+            <a:r>
+              <a:rPr lang="en-US" dirty="0"/>
+              <a:t>, not the vocabulary.</a:t>
             </a:r>
           </a:p>
           <a:p>
@@ -7047,6 +7218,7 @@
               </a:defRPr>
             </a:pPr>
             <a:r>
+              <a:rPr lang="en-US" dirty="0"/>
               <a:t>The experimental variable: which negatives the probe trains against —</a:t>
             </a:r>
           </a:p>
@@ -7063,7 +7235,24 @@
               </a:defRPr>
             </a:pPr>
             <a:r>
-              <a:t>random unrelated concepts  vs  graph siblings (e.g. ManipulativeCommunication, Misdirection's nearest confuser).</a:t>
+              <a:rPr lang="en-US" dirty="0"/>
+              <a:t>random unrelated concepts  vs  graph siblings (e.g. </a:t>
+            </a:r>
+            <a:r>
+              <a:rPr lang="en-US" dirty="0" err="1"/>
+              <a:t>ManipulativeCommunication</a:t>
+            </a:r>
+            <a:r>
+              <a:rPr lang="en-US" dirty="0"/>
+              <a:t>, Misdirection's nearest </a:t>
+            </a:r>
+            <a:r>
+              <a:rPr lang="en-US" dirty="0" err="1"/>
+              <a:t>confuser</a:t>
+            </a:r>
+            <a:r>
+              <a:rPr lang="en-US" dirty="0"/>
+              <a:t>).</a:t>
             </a:r>
           </a:p>
         </p:txBody>
@@ -7071,7 +7260,7 @@
     </p:spTree>
     <p:extLst>
       <p:ext uri="{BB962C8B-B14F-4D97-AF65-F5344CB8AC3E}">
-        <p14:creationId xmlns:p14="http://schemas.microsoft.com/office/powerpoint/2010/main" val="1982414027"/>
+        <p14:creationId xmlns:p14="http://schemas.microsoft.com/office/powerpoint/2010/main" val="3397760978"/>
       </p:ext>
     </p:extLst>
   </p:cSld>
@@ -7425,7 +7614,16 @@
                         </a:defRPr>
                       </a:pPr>
                       <a:r>
-                        <a:t>direct-neighbour negatives</a:t>
+                        <a:rPr dirty="0"/>
+                        <a:t>direct-</a:t>
+                      </a:r>
+                      <a:r>
+                        <a:rPr dirty="0" err="1"/>
+                        <a:t>neighbour</a:t>
+                      </a:r>
+                      <a:r>
+                        <a:rPr dirty="0"/>
+                        <a:t> negatives</a:t>
                       </a:r>
                     </a:p>
                   </a:txBody>

</xml_diff>